<commit_message>
v2: add three Before→After examples (bad paraphrase, correct rewrite, when to quote)
</commit_message>
<xml_diff>
--- a/Rewriting_Proofreading_Session4.2.pptx
+++ b/Rewriting_Proofreading_Session4.2.pptx
@@ -12,6 +12,7 @@
     <p:sldId id="260" r:id="rId11"/>
     <p:sldId id="261" r:id="rId12"/>
     <p:sldId id="262" r:id="rId13"/>
+    <p:sldId id="263" r:id="rId14"/>
   </p:sldIdLst>
   <p:sldSz cx="12191695" cy="6858000" type="screen4x3"/>
   <p:notesSz cx="6858000" cy="9144000"/>
@@ -3168,7 +3169,7 @@
           <a:lstStyle/>
           <a:p>
             <a:pPr algn="l">
-              <a:defRPr sz="3600" b="1">
+              <a:defRPr sz="3600" b="1" i="0">
                 <a:solidFill>
                   <a:srgbClr val="FFFFFF"/>
                 </a:solidFill>
@@ -3204,7 +3205,7 @@
           <a:lstStyle/>
           <a:p>
             <a:pPr algn="l">
-              <a:defRPr sz="4800" b="1">
+              <a:defRPr sz="4800" b="1" i="0">
                 <a:solidFill>
                   <a:srgbClr val="FFFFFF"/>
                 </a:solidFill>
@@ -3283,7 +3284,7 @@
           <a:lstStyle/>
           <a:p>
             <a:pPr algn="l">
-              <a:defRPr sz="2000" b="0">
+              <a:defRPr sz="2000" b="0" i="0">
                 <a:solidFill>
                   <a:srgbClr val="FFFFFF"/>
                 </a:solidFill>
@@ -3431,7 +3432,7 @@
           <a:lstStyle/>
           <a:p>
             <a:pPr algn="l">
-              <a:defRPr sz="1800" b="1">
+              <a:defRPr sz="1800" b="1" i="0">
                 <a:solidFill>
                   <a:srgbClr val="502379"/>
                 </a:solidFill>
@@ -3467,7 +3468,7 @@
           <a:lstStyle/>
           <a:p>
             <a:pPr algn="r">
-              <a:defRPr sz="1200" b="0">
+              <a:defRPr sz="1200" b="0" i="0">
                 <a:solidFill>
                   <a:srgbClr val="502379"/>
                 </a:solidFill>
@@ -3503,7 +3504,7 @@
           <a:lstStyle/>
           <a:p>
             <a:pPr algn="l">
-              <a:defRPr sz="2800" b="1">
+              <a:defRPr sz="2800" b="1" i="0">
                 <a:solidFill>
                   <a:srgbClr val="502379"/>
                 </a:solidFill>
@@ -3518,66 +3519,14 @@
       </p:sp>
       <p:sp>
         <p:nvSpPr>
-          <p:cNvPr id="7" name="Oval 6"/>
-          <p:cNvSpPr/>
-          <p:nvPr/>
-        </p:nvSpPr>
-        <p:spPr>
-          <a:xfrm>
-            <a:off x="10820095" y="274320"/>
-            <a:ext cx="731520" cy="731520"/>
-          </a:xfrm>
-          <a:prstGeom prst="ellipse">
-            <a:avLst/>
-          </a:prstGeom>
-          <a:solidFill>
-            <a:srgbClr val="4A90D9"/>
-          </a:solidFill>
-          <a:ln>
-            <a:noFill/>
-          </a:ln>
-        </p:spPr>
-        <p:style>
-          <a:lnRef idx="1">
-            <a:schemeClr val="accent1"/>
-          </a:lnRef>
-          <a:fillRef idx="3">
-            <a:schemeClr val="accent1"/>
-          </a:fillRef>
-          <a:effectRef idx="2">
-            <a:schemeClr val="accent1"/>
-          </a:effectRef>
-          <a:fontRef idx="minor">
-            <a:schemeClr val="lt1"/>
-          </a:fontRef>
-        </p:style>
-        <p:txBody>
-          <a:bodyPr rtlCol="0" anchor="ctr" wrap="none"/>
-          <a:lstStyle/>
-          <a:p>
-            <a:pPr algn="ctr">
-              <a:defRPr sz="2400">
-                <a:solidFill>
-                  <a:srgbClr val="FFFFFF"/>
-                </a:solidFill>
-              </a:defRPr>
-            </a:pPr>
-            <a:r>
-              <a:t>⏸</a:t>
-            </a:r>
-          </a:p>
-        </p:txBody>
-      </p:sp>
-      <p:sp>
-        <p:nvSpPr>
-          <p:cNvPr id="8" name="TextBox 7"/>
+          <p:cNvPr id="7" name="TextBox 6"/>
           <p:cNvSpPr txBox="1"/>
           <p:nvPr/>
         </p:nvSpPr>
         <p:spPr>
           <a:xfrm>
             <a:off x="640080" y="1463040"/>
-            <a:ext cx="7315200" cy="3200400"/>
+            <a:ext cx="9144000" cy="3200400"/>
           </a:xfrm>
           <a:prstGeom prst="rect">
             <a:avLst/>
@@ -3590,11 +3539,11 @@
           </a:bodyPr>
           <a:lstStyle/>
           <a:p>
-            <a:pPr>
+            <a:pPr algn="l">
               <a:spcAft>
-                <a:spcPts val="3200"/>
+                <a:spcPts val="1200"/>
               </a:spcAft>
-              <a:defRPr sz="2000" b="1">
+              <a:defRPr sz="2000" b="1" i="0">
                 <a:solidFill>
                   <a:srgbClr val="000000"/>
                 </a:solidFill>
@@ -3606,11 +3555,11 @@
             </a:r>
           </a:p>
           <a:p>
-            <a:pPr>
+            <a:pPr algn="l">
               <a:spcAft>
-                <a:spcPts val="3200"/>
+                <a:spcPts val="1200"/>
               </a:spcAft>
-              <a:defRPr sz="2000" b="1">
+              <a:defRPr sz="2000" b="1" i="0">
                 <a:solidFill>
                   <a:srgbClr val="000000"/>
                 </a:solidFill>
@@ -3622,11 +3571,11 @@
             </a:r>
           </a:p>
           <a:p>
-            <a:pPr>
+            <a:pPr algn="l">
               <a:spcAft>
-                <a:spcPts val="3200"/>
+                <a:spcPts val="1200"/>
               </a:spcAft>
-              <a:defRPr sz="2000" b="1">
+              <a:defRPr sz="2000" b="1" i="0">
                 <a:solidFill>
                   <a:srgbClr val="000000"/>
                 </a:solidFill>
@@ -3638,11 +3587,11 @@
             </a:r>
           </a:p>
           <a:p>
-            <a:pPr>
+            <a:pPr algn="l">
               <a:spcAft>
-                <a:spcPts val="3200"/>
+                <a:spcPts val="1200"/>
               </a:spcAft>
-              <a:defRPr sz="2000" b="1">
+              <a:defRPr sz="2000" b="1" i="0">
                 <a:solidFill>
                   <a:srgbClr val="000000"/>
                 </a:solidFill>
@@ -3790,7 +3739,7 @@
           <a:lstStyle/>
           <a:p>
             <a:pPr algn="l">
-              <a:defRPr sz="1800" b="1">
+              <a:defRPr sz="1800" b="1" i="0">
                 <a:solidFill>
                   <a:srgbClr val="502379"/>
                 </a:solidFill>
@@ -3826,7 +3775,7 @@
           <a:lstStyle/>
           <a:p>
             <a:pPr algn="r">
-              <a:defRPr sz="1200" b="0">
+              <a:defRPr sz="1200" b="0" i="0">
                 <a:solidFill>
                   <a:srgbClr val="502379"/>
                 </a:solidFill>
@@ -3862,7 +3811,7 @@
           <a:lstStyle/>
           <a:p>
             <a:pPr algn="l">
-              <a:defRPr sz="2800" b="1">
+              <a:defRPr sz="2800" b="1" i="0">
                 <a:solidFill>
                   <a:srgbClr val="502379"/>
                 </a:solidFill>
@@ -3877,66 +3826,14 @@
       </p:sp>
       <p:sp>
         <p:nvSpPr>
-          <p:cNvPr id="7" name="Oval 6"/>
-          <p:cNvSpPr/>
-          <p:nvPr/>
-        </p:nvSpPr>
-        <p:spPr>
-          <a:xfrm>
-            <a:off x="10820095" y="274320"/>
-            <a:ext cx="731520" cy="731520"/>
-          </a:xfrm>
-          <a:prstGeom prst="ellipse">
-            <a:avLst/>
-          </a:prstGeom>
-          <a:solidFill>
-            <a:srgbClr val="4A90D9"/>
-          </a:solidFill>
-          <a:ln>
-            <a:noFill/>
-          </a:ln>
-        </p:spPr>
-        <p:style>
-          <a:lnRef idx="1">
-            <a:schemeClr val="accent1"/>
-          </a:lnRef>
-          <a:fillRef idx="3">
-            <a:schemeClr val="accent1"/>
-          </a:fillRef>
-          <a:effectRef idx="2">
-            <a:schemeClr val="accent1"/>
-          </a:effectRef>
-          <a:fontRef idx="minor">
-            <a:schemeClr val="lt1"/>
-          </a:fontRef>
-        </p:style>
-        <p:txBody>
-          <a:bodyPr rtlCol="0" anchor="ctr" wrap="none"/>
-          <a:lstStyle/>
-          <a:p>
-            <a:pPr algn="ctr">
-              <a:defRPr sz="2400">
-                <a:solidFill>
-                  <a:srgbClr val="FFFFFF"/>
-                </a:solidFill>
-              </a:defRPr>
-            </a:pPr>
-            <a:r>
-              <a:t>⏸</a:t>
-            </a:r>
-          </a:p>
-        </p:txBody>
-      </p:sp>
-      <p:sp>
-        <p:nvSpPr>
-          <p:cNvPr id="8" name="TextBox 7"/>
+          <p:cNvPr id="7" name="TextBox 6"/>
           <p:cNvSpPr txBox="1"/>
           <p:nvPr/>
         </p:nvSpPr>
         <p:spPr>
           <a:xfrm>
             <a:off x="640080" y="1463040"/>
-            <a:ext cx="7315200" cy="3200400"/>
+            <a:ext cx="9144000" cy="3200400"/>
           </a:xfrm>
           <a:prstGeom prst="rect">
             <a:avLst/>
@@ -3949,11 +3846,11 @@
           </a:bodyPr>
           <a:lstStyle/>
           <a:p>
-            <a:pPr>
+            <a:pPr algn="l">
               <a:spcAft>
-                <a:spcPts val="3200"/>
+                <a:spcPts val="1200"/>
               </a:spcAft>
-              <a:defRPr sz="2000" b="1">
+              <a:defRPr sz="2000" b="1" i="0">
                 <a:solidFill>
                   <a:srgbClr val="000000"/>
                 </a:solidFill>
@@ -3965,11 +3862,11 @@
             </a:r>
           </a:p>
           <a:p>
-            <a:pPr>
+            <a:pPr algn="l">
               <a:spcAft>
-                <a:spcPts val="3200"/>
+                <a:spcPts val="1200"/>
               </a:spcAft>
-              <a:defRPr sz="2000" b="1">
+              <a:defRPr sz="2000" b="1" i="0">
                 <a:solidFill>
                   <a:srgbClr val="000000"/>
                 </a:solidFill>
@@ -3977,15 +3874,15 @@
               </a:defRPr>
             </a:pPr>
             <a:r>
-              <a:t>●  Highlighted text = matched source, not cited correctly</a:t>
-            </a:r>
-          </a:p>
-          <a:p>
-            <a:pPr>
+              <a:t>●  Pink text = matched source, not cited correctly</a:t>
+            </a:r>
+          </a:p>
+          <a:p>
+            <a:pPr algn="l">
               <a:spcAft>
-                <a:spcPts val="3200"/>
+                <a:spcPts val="1200"/>
               </a:spcAft>
-              <a:defRPr sz="2000" b="1">
+              <a:defRPr sz="2000" b="1" i="0">
                 <a:solidFill>
                   <a:srgbClr val="000000"/>
                 </a:solidFill>
@@ -3997,11 +3894,11 @@
             </a:r>
           </a:p>
           <a:p>
-            <a:pPr>
+            <a:pPr algn="l">
               <a:spcAft>
-                <a:spcPts val="3200"/>
+                <a:spcPts val="1200"/>
               </a:spcAft>
-              <a:defRPr sz="2000" b="1">
+              <a:defRPr sz="2000" b="1" i="0">
                 <a:solidFill>
                   <a:srgbClr val="000000"/>
                 </a:solidFill>
@@ -4149,7 +4046,7 @@
           <a:lstStyle/>
           <a:p>
             <a:pPr algn="l">
-              <a:defRPr sz="1800" b="1">
+              <a:defRPr sz="1800" b="1" i="0">
                 <a:solidFill>
                   <a:srgbClr val="502379"/>
                 </a:solidFill>
@@ -4185,7 +4082,7 @@
           <a:lstStyle/>
           <a:p>
             <a:pPr algn="r">
-              <a:defRPr sz="1200" b="0">
+              <a:defRPr sz="1200" b="0" i="0">
                 <a:solidFill>
                   <a:srgbClr val="502379"/>
                 </a:solidFill>
@@ -4221,7 +4118,7 @@
           <a:lstStyle/>
           <a:p>
             <a:pPr algn="l">
-              <a:defRPr sz="2800" b="1">
+              <a:defRPr sz="2800" b="1" i="0">
                 <a:solidFill>
                   <a:srgbClr val="502379"/>
                 </a:solidFill>
@@ -4236,66 +4133,14 @@
       </p:sp>
       <p:sp>
         <p:nvSpPr>
-          <p:cNvPr id="7" name="Oval 6"/>
-          <p:cNvSpPr/>
-          <p:nvPr/>
-        </p:nvSpPr>
-        <p:spPr>
-          <a:xfrm>
-            <a:off x="10820095" y="274320"/>
-            <a:ext cx="731520" cy="731520"/>
-          </a:xfrm>
-          <a:prstGeom prst="ellipse">
-            <a:avLst/>
-          </a:prstGeom>
-          <a:solidFill>
-            <a:srgbClr val="4A90D9"/>
-          </a:solidFill>
-          <a:ln>
-            <a:noFill/>
-          </a:ln>
-        </p:spPr>
-        <p:style>
-          <a:lnRef idx="1">
-            <a:schemeClr val="accent1"/>
-          </a:lnRef>
-          <a:fillRef idx="3">
-            <a:schemeClr val="accent1"/>
-          </a:fillRef>
-          <a:effectRef idx="2">
-            <a:schemeClr val="accent1"/>
-          </a:effectRef>
-          <a:fontRef idx="minor">
-            <a:schemeClr val="lt1"/>
-          </a:fontRef>
-        </p:style>
-        <p:txBody>
-          <a:bodyPr rtlCol="0" anchor="ctr" wrap="none"/>
-          <a:lstStyle/>
-          <a:p>
-            <a:pPr algn="ctr">
-              <a:defRPr sz="2400">
-                <a:solidFill>
-                  <a:srgbClr val="FFFFFF"/>
-                </a:solidFill>
-              </a:defRPr>
-            </a:pPr>
-            <a:r>
-              <a:t>⏸</a:t>
-            </a:r>
-          </a:p>
-        </p:txBody>
-      </p:sp>
-      <p:sp>
-        <p:nvSpPr>
-          <p:cNvPr id="8" name="TextBox 7"/>
+          <p:cNvPr id="7" name="TextBox 6"/>
           <p:cNvSpPr txBox="1"/>
           <p:nvPr/>
         </p:nvSpPr>
         <p:spPr>
           <a:xfrm>
             <a:off x="640080" y="1463040"/>
-            <a:ext cx="7315200" cy="3200400"/>
+            <a:ext cx="9144000" cy="3200400"/>
           </a:xfrm>
           <a:prstGeom prst="rect">
             <a:avLst/>
@@ -4308,11 +4153,11 @@
           </a:bodyPr>
           <a:lstStyle/>
           <a:p>
-            <a:pPr>
+            <a:pPr algn="l">
               <a:spcAft>
-                <a:spcPts val="3200"/>
+                <a:spcPts val="1200"/>
               </a:spcAft>
-              <a:defRPr sz="2000" b="1">
+              <a:defRPr sz="2000" b="1" i="0">
                 <a:solidFill>
                   <a:srgbClr val="000000"/>
                 </a:solidFill>
@@ -4324,11 +4169,11 @@
             </a:r>
           </a:p>
           <a:p>
-            <a:pPr>
+            <a:pPr algn="l">
               <a:spcAft>
-                <a:spcPts val="3200"/>
+                <a:spcPts val="1200"/>
               </a:spcAft>
-              <a:defRPr sz="2000" b="1">
+              <a:defRPr sz="2000" b="1" i="0">
                 <a:solidFill>
                   <a:srgbClr val="000000"/>
                 </a:solidFill>
@@ -4340,11 +4185,11 @@
             </a:r>
           </a:p>
           <a:p>
-            <a:pPr>
+            <a:pPr algn="l">
               <a:spcAft>
-                <a:spcPts val="3200"/>
+                <a:spcPts val="1200"/>
               </a:spcAft>
-              <a:defRPr sz="2000" b="1">
+              <a:defRPr sz="2000" b="1" i="0">
                 <a:solidFill>
                   <a:srgbClr val="000000"/>
                 </a:solidFill>
@@ -4356,11 +4201,11 @@
             </a:r>
           </a:p>
           <a:p>
-            <a:pPr>
+            <a:pPr algn="l">
               <a:spcAft>
-                <a:spcPts val="3200"/>
+                <a:spcPts val="1200"/>
               </a:spcAft>
-              <a:defRPr sz="2000" b="1">
+              <a:defRPr sz="2000" b="1" i="0">
                 <a:solidFill>
                   <a:srgbClr val="000000"/>
                 </a:solidFill>
@@ -4508,7 +4353,7 @@
           <a:lstStyle/>
           <a:p>
             <a:pPr algn="l">
-              <a:defRPr sz="1800" b="1">
+              <a:defRPr sz="1800" b="1" i="0">
                 <a:solidFill>
                   <a:srgbClr val="502379"/>
                 </a:solidFill>
@@ -4544,7 +4389,7 @@
           <a:lstStyle/>
           <a:p>
             <a:pPr algn="r">
-              <a:defRPr sz="1200" b="0">
+              <a:defRPr sz="1200" b="0" i="0">
                 <a:solidFill>
                   <a:srgbClr val="502379"/>
                 </a:solidFill>
@@ -4580,7 +4425,7 @@
           <a:lstStyle/>
           <a:p>
             <a:pPr algn="l">
-              <a:defRPr sz="2800" b="1">
+              <a:defRPr sz="2800" b="1" i="0">
                 <a:solidFill>
                   <a:srgbClr val="502379"/>
                 </a:solidFill>
@@ -4595,66 +4440,14 @@
       </p:sp>
       <p:sp>
         <p:nvSpPr>
-          <p:cNvPr id="7" name="Oval 6"/>
-          <p:cNvSpPr/>
-          <p:nvPr/>
-        </p:nvSpPr>
-        <p:spPr>
-          <a:xfrm>
-            <a:off x="10820095" y="274320"/>
-            <a:ext cx="731520" cy="731520"/>
-          </a:xfrm>
-          <a:prstGeom prst="ellipse">
-            <a:avLst/>
-          </a:prstGeom>
-          <a:solidFill>
-            <a:srgbClr val="4A90D9"/>
-          </a:solidFill>
-          <a:ln>
-            <a:noFill/>
-          </a:ln>
-        </p:spPr>
-        <p:style>
-          <a:lnRef idx="1">
-            <a:schemeClr val="accent1"/>
-          </a:lnRef>
-          <a:fillRef idx="3">
-            <a:schemeClr val="accent1"/>
-          </a:fillRef>
-          <a:effectRef idx="2">
-            <a:schemeClr val="accent1"/>
-          </a:effectRef>
-          <a:fontRef idx="minor">
-            <a:schemeClr val="lt1"/>
-          </a:fontRef>
-        </p:style>
-        <p:txBody>
-          <a:bodyPr rtlCol="0" anchor="ctr" wrap="none"/>
-          <a:lstStyle/>
-          <a:p>
-            <a:pPr algn="ctr">
-              <a:defRPr sz="2400">
-                <a:solidFill>
-                  <a:srgbClr val="FFFFFF"/>
-                </a:solidFill>
-              </a:defRPr>
-            </a:pPr>
-            <a:r>
-              <a:t>⏸</a:t>
-            </a:r>
-          </a:p>
-        </p:txBody>
-      </p:sp>
-      <p:sp>
-        <p:nvSpPr>
-          <p:cNvPr id="8" name="TextBox 7"/>
+          <p:cNvPr id="7" name="TextBox 6"/>
           <p:cNvSpPr txBox="1"/>
           <p:nvPr/>
         </p:nvSpPr>
         <p:spPr>
           <a:xfrm>
             <a:off x="640080" y="1463040"/>
-            <a:ext cx="7315200" cy="3200400"/>
+            <a:ext cx="9144000" cy="3200400"/>
           </a:xfrm>
           <a:prstGeom prst="rect">
             <a:avLst/>
@@ -4667,11 +4460,11 @@
           </a:bodyPr>
           <a:lstStyle/>
           <a:p>
-            <a:pPr>
+            <a:pPr algn="l">
               <a:spcAft>
-                <a:spcPts val="3200"/>
+                <a:spcPts val="1200"/>
               </a:spcAft>
-              <a:defRPr sz="2000" b="1">
+              <a:defRPr sz="2000" b="1" i="0">
                 <a:solidFill>
                   <a:srgbClr val="000000"/>
                 </a:solidFill>
@@ -4683,11 +4476,11 @@
             </a:r>
           </a:p>
           <a:p>
-            <a:pPr>
+            <a:pPr algn="l">
               <a:spcAft>
-                <a:spcPts val="3200"/>
+                <a:spcPts val="1200"/>
               </a:spcAft>
-              <a:defRPr sz="2000" b="1">
+              <a:defRPr sz="2000" b="1" i="0">
                 <a:solidFill>
                   <a:srgbClr val="000000"/>
                 </a:solidFill>
@@ -4699,11 +4492,11 @@
             </a:r>
           </a:p>
           <a:p>
-            <a:pPr>
+            <a:pPr algn="l">
               <a:spcAft>
-                <a:spcPts val="3200"/>
+                <a:spcPts val="1200"/>
               </a:spcAft>
-              <a:defRPr sz="2000" b="1">
+              <a:defRPr sz="2000" b="1" i="0">
                 <a:solidFill>
                   <a:srgbClr val="000000"/>
                 </a:solidFill>
@@ -4715,11 +4508,11 @@
             </a:r>
           </a:p>
           <a:p>
-            <a:pPr>
+            <a:pPr algn="l">
               <a:spcAft>
-                <a:spcPts val="3200"/>
+                <a:spcPts val="1200"/>
               </a:spcAft>
-              <a:defRPr sz="2000" b="1">
+              <a:defRPr sz="2000" b="1" i="0">
                 <a:solidFill>
                   <a:srgbClr val="000000"/>
                 </a:solidFill>
@@ -4867,7 +4660,7 @@
           <a:lstStyle/>
           <a:p>
             <a:pPr algn="l">
-              <a:defRPr sz="1800" b="1">
+              <a:defRPr sz="1800" b="1" i="0">
                 <a:solidFill>
                   <a:srgbClr val="502379"/>
                 </a:solidFill>
@@ -4875,7 +4668,7 @@
               </a:defRPr>
             </a:pPr>
             <a:r>
-              <a:t>Summarise + cite correctly = no plagiarism</a:t>
+              <a:t>Paraphrase = read → cover → write from memory → check</a:t>
             </a:r>
           </a:p>
         </p:txBody>
@@ -4903,7 +4696,7 @@
           <a:lstStyle/>
           <a:p>
             <a:pPr algn="r">
-              <a:defRPr sz="1200" b="0">
+              <a:defRPr sz="1200" b="0" i="0">
                 <a:solidFill>
                   <a:srgbClr val="502379"/>
                 </a:solidFill>
@@ -4939,7 +4732,7 @@
           <a:lstStyle/>
           <a:p>
             <a:pPr algn="l">
-              <a:defRPr sz="2800" b="1">
+              <a:defRPr sz="2800" b="1" i="0">
                 <a:solidFill>
                   <a:srgbClr val="502379"/>
                 </a:solidFill>
@@ -4947,7 +4740,7 @@
               </a:defRPr>
             </a:pPr>
             <a:r>
-              <a:t>Solutions: How to Rewrite Correctly</a:t>
+              <a:t>Three Examples: Before → After</a:t>
             </a:r>
           </a:p>
         </p:txBody>
@@ -4960,8 +4753,8 @@
         </p:nvSpPr>
         <p:spPr>
           <a:xfrm>
-            <a:off x="640080" y="868680"/>
-            <a:ext cx="10058400" cy="457200"/>
+            <a:off x="640080" y="1325880"/>
+            <a:ext cx="1828800" cy="320040"/>
           </a:xfrm>
           <a:prstGeom prst="rect">
             <a:avLst/>
@@ -4975,81 +4768,29 @@
           <a:lstStyle/>
           <a:p>
             <a:pPr algn="l">
-              <a:defRPr sz="2000" b="1">
-                <a:solidFill>
-                  <a:srgbClr val="000000"/>
-                </a:solidFill>
-                <a:latin typeface="Calibri"/>
-              </a:defRPr>
-            </a:pPr>
-            <a:r>
-              <a:t>Two key strategies</a:t>
-            </a:r>
-          </a:p>
-        </p:txBody>
-      </p:sp>
-      <p:sp>
-        <p:nvSpPr>
-          <p:cNvPr id="8" name="Oval 7"/>
-          <p:cNvSpPr/>
-          <p:nvPr/>
-        </p:nvSpPr>
-        <p:spPr>
-          <a:xfrm>
-            <a:off x="10820095" y="274320"/>
-            <a:ext cx="731520" cy="731520"/>
-          </a:xfrm>
-          <a:prstGeom prst="ellipse">
-            <a:avLst/>
-          </a:prstGeom>
-          <a:solidFill>
-            <a:srgbClr val="4A90D9"/>
-          </a:solidFill>
-          <a:ln>
-            <a:noFill/>
-          </a:ln>
-        </p:spPr>
-        <p:style>
-          <a:lnRef idx="1">
-            <a:schemeClr val="accent1"/>
-          </a:lnRef>
-          <a:fillRef idx="3">
-            <a:schemeClr val="accent1"/>
-          </a:fillRef>
-          <a:effectRef idx="2">
-            <a:schemeClr val="accent1"/>
-          </a:effectRef>
-          <a:fontRef idx="minor">
-            <a:schemeClr val="lt1"/>
-          </a:fontRef>
-        </p:style>
-        <p:txBody>
-          <a:bodyPr rtlCol="0" anchor="ctr" wrap="none"/>
-          <a:lstStyle/>
-          <a:p>
-            <a:pPr algn="ctr">
-              <a:defRPr sz="2400">
-                <a:solidFill>
-                  <a:srgbClr val="FFFFFF"/>
-                </a:solidFill>
-              </a:defRPr>
-            </a:pPr>
-            <a:r>
-              <a:t>⏸</a:t>
-            </a:r>
-          </a:p>
-        </p:txBody>
-      </p:sp>
-      <p:sp>
-        <p:nvSpPr>
-          <p:cNvPr id="9" name="TextBox 8"/>
+              <a:defRPr sz="1500" b="1" i="0">
+                <a:solidFill>
+                  <a:srgbClr val="FF0000"/>
+                </a:solidFill>
+                <a:latin typeface="Calibri"/>
+              </a:defRPr>
+            </a:pPr>
+            <a:r>
+              <a:t>Example 1: ❌ Bad Paraphrase</a:t>
+            </a:r>
+          </a:p>
+        </p:txBody>
+      </p:sp>
+      <p:sp>
+        <p:nvSpPr>
+          <p:cNvPr id="8" name="TextBox 7"/>
           <p:cNvSpPr txBox="1"/>
           <p:nvPr/>
         </p:nvSpPr>
         <p:spPr>
           <a:xfrm>
             <a:off x="640080" y="1645920"/>
-            <a:ext cx="9144000" cy="4114800"/>
+            <a:ext cx="5303520" cy="1371600"/>
           </a:xfrm>
           <a:prstGeom prst="rect">
             <a:avLst/>
@@ -5062,11 +4803,27 @@
           </a:bodyPr>
           <a:lstStyle/>
           <a:p>
-            <a:pPr>
+            <a:pPr algn="l">
               <a:spcAft>
-                <a:spcPts val="2800"/>
+                <a:spcPts val="400"/>
               </a:spcAft>
-              <a:defRPr sz="1800" b="1">
+              <a:defRPr sz="1300" b="1" i="0">
+                <a:solidFill>
+                  <a:srgbClr val="0070C0"/>
+                </a:solidFill>
+                <a:latin typeface="Calibri"/>
+              </a:defRPr>
+            </a:pPr>
+            <a:r>
+              <a:t>SOURCE (Cunningham &amp; Eastin, 2015):</a:t>
+            </a:r>
+          </a:p>
+          <a:p>
+            <a:pPr algn="l">
+              <a:spcAft>
+                <a:spcPts val="400"/>
+              </a:spcAft>
+              <a:defRPr sz="1200" b="1" i="1">
                 <a:solidFill>
                   <a:srgbClr val="000000"/>
                 </a:solidFill>
@@ -5074,15 +4831,31 @@
               </a:defRPr>
             </a:pPr>
             <a:r>
-              <a:t>●  Strategy 1: Summarise in your own words</a:t>
-            </a:r>
-          </a:p>
-          <a:p>
-            <a:pPr>
+              <a:t>"...developments in social media also provide sport fans with the opportunity to tweet, text, and Facebook, all while watching the game, which provides a new and enriched fandom experience."</a:t>
+            </a:r>
+          </a:p>
+          <a:p>
+            <a:pPr algn="l">
               <a:spcAft>
-                <a:spcPts val="2800"/>
+                <a:spcPts val="400"/>
               </a:spcAft>
-              <a:defRPr sz="1800" b="1">
+              <a:defRPr sz="1300" b="1" i="0">
+                <a:solidFill>
+                  <a:srgbClr val="FF0000"/>
+                </a:solidFill>
+                <a:latin typeface="Calibri"/>
+              </a:defRPr>
+            </a:pPr>
+            <a:r>
+              <a:t>STUDENT WROTE:</a:t>
+            </a:r>
+          </a:p>
+          <a:p>
+            <a:pPr algn="l">
+              <a:spcAft>
+                <a:spcPts val="400"/>
+              </a:spcAft>
+              <a:defRPr sz="1200" b="1" i="1">
                 <a:solidFill>
                   <a:srgbClr val="000000"/>
                 </a:solidFill>
@@ -5090,15 +4863,106 @@
               </a:defRPr>
             </a:pPr>
             <a:r>
-              <a:t>    → Read → cover → write from memory → check</a:t>
-            </a:r>
-          </a:p>
-          <a:p>
-            <a:pPr>
+              <a:t>"...the development of social media also provides sports enthusiasts with the opportunity to tweet, text and Facebook while watching the game, which provides a new and rich fan experience."</a:t>
+            </a:r>
+          </a:p>
+          <a:p>
+            <a:pPr algn="l">
               <a:spcAft>
-                <a:spcPts val="2800"/>
+                <a:spcPts val="0"/>
               </a:spcAft>
-              <a:defRPr sz="1800" b="1">
+              <a:defRPr sz="1300" b="1" i="0">
+                <a:solidFill>
+                  <a:srgbClr val="FF0000"/>
+                </a:solidFill>
+                <a:latin typeface="Calibri"/>
+              </a:defRPr>
+            </a:pPr>
+            <a:r>
+              <a:t>❌ Only changed 3 words. Turnitin still flags it.</a:t>
+            </a:r>
+          </a:p>
+        </p:txBody>
+      </p:sp>
+      <p:sp>
+        <p:nvSpPr>
+          <p:cNvPr id="9" name="TextBox 8"/>
+          <p:cNvSpPr txBox="1"/>
+          <p:nvPr/>
+        </p:nvSpPr>
+        <p:spPr>
+          <a:xfrm>
+            <a:off x="6400800" y="1325880"/>
+            <a:ext cx="2286000" cy="320040"/>
+          </a:xfrm>
+          <a:prstGeom prst="rect">
+            <a:avLst/>
+          </a:prstGeom>
+          <a:noFill/>
+        </p:spPr>
+        <p:txBody>
+          <a:bodyPr wrap="square">
+            <a:spAutoFit/>
+          </a:bodyPr>
+          <a:lstStyle/>
+          <a:p>
+            <a:pPr algn="l">
+              <a:defRPr sz="1500" b="1" i="0">
+                <a:solidFill>
+                  <a:srgbClr val="008040"/>
+                </a:solidFill>
+                <a:latin typeface="Calibri"/>
+              </a:defRPr>
+            </a:pPr>
+            <a:r>
+              <a:t>Example 2: ✅ Correct Rewrite</a:t>
+            </a:r>
+          </a:p>
+        </p:txBody>
+      </p:sp>
+      <p:sp>
+        <p:nvSpPr>
+          <p:cNvPr id="10" name="TextBox 9"/>
+          <p:cNvSpPr txBox="1"/>
+          <p:nvPr/>
+        </p:nvSpPr>
+        <p:spPr>
+          <a:xfrm>
+            <a:off x="6400800" y="1645920"/>
+            <a:ext cx="5303520" cy="1371600"/>
+          </a:xfrm>
+          <a:prstGeom prst="rect">
+            <a:avLst/>
+          </a:prstGeom>
+          <a:noFill/>
+        </p:spPr>
+        <p:txBody>
+          <a:bodyPr wrap="square">
+            <a:spAutoFit/>
+          </a:bodyPr>
+          <a:lstStyle/>
+          <a:p>
+            <a:pPr algn="l">
+              <a:spcAft>
+                <a:spcPts val="400"/>
+              </a:spcAft>
+              <a:defRPr sz="1300" b="1" i="0">
+                <a:solidFill>
+                  <a:srgbClr val="008040"/>
+                </a:solidFill>
+                <a:latin typeface="Calibri"/>
+              </a:defRPr>
+            </a:pPr>
+            <a:r>
+              <a:t>CORRECT REWRITE:</a:t>
+            </a:r>
+          </a:p>
+          <a:p>
+            <a:pPr algn="l">
+              <a:spcAft>
+                <a:spcPts val="400"/>
+              </a:spcAft>
+              <a:defRPr sz="1200" b="1" i="1">
                 <a:solidFill>
                   <a:srgbClr val="000000"/>
                 </a:solidFill>
@@ -5106,15 +4970,106 @@
               </a:defRPr>
             </a:pPr>
             <a:r>
-              <a:t>●  Strategy 2: Use correct citation format</a:t>
-            </a:r>
-          </a:p>
-          <a:p>
-            <a:pPr>
+              <a:t>"Social media has brought a 'new and rich' experience to sports fans who can tweet, send text messages or update their Facebook status at the same time as watching the game (Pegoraro, 2013 cited in Cunningham and Eastin, 2015, p.289)."</a:t>
+            </a:r>
+          </a:p>
+          <a:p>
+            <a:pPr algn="l">
               <a:spcAft>
-                <a:spcPts val="2800"/>
+                <a:spcPts val="0"/>
               </a:spcAft>
-              <a:defRPr sz="1800" b="1">
+              <a:defRPr sz="1300" b="1" i="0">
+                <a:solidFill>
+                  <a:srgbClr val="008040"/>
+                </a:solidFill>
+                <a:latin typeface="Calibri"/>
+              </a:defRPr>
+            </a:pPr>
+            <a:r>
+              <a:t>✅ Changed subject + restructured sentence + secondary citation</a:t>
+            </a:r>
+          </a:p>
+        </p:txBody>
+      </p:sp>
+      <p:sp>
+        <p:nvSpPr>
+          <p:cNvPr id="11" name="TextBox 10"/>
+          <p:cNvSpPr txBox="1"/>
+          <p:nvPr/>
+        </p:nvSpPr>
+        <p:spPr>
+          <a:xfrm>
+            <a:off x="640080" y="3520440"/>
+            <a:ext cx="2743200" cy="320040"/>
+          </a:xfrm>
+          <a:prstGeom prst="rect">
+            <a:avLst/>
+          </a:prstGeom>
+          <a:noFill/>
+        </p:spPr>
+        <p:txBody>
+          <a:bodyPr wrap="square">
+            <a:spAutoFit/>
+          </a:bodyPr>
+          <a:lstStyle/>
+          <a:p>
+            <a:pPr algn="l">
+              <a:defRPr sz="1500" b="1" i="0">
+                <a:solidFill>
+                  <a:srgbClr val="0070C0"/>
+                </a:solidFill>
+                <a:latin typeface="Calibri"/>
+              </a:defRPr>
+            </a:pPr>
+            <a:r>
+              <a:t>Example 3: 🔤 When to Use Quotes</a:t>
+            </a:r>
+          </a:p>
+        </p:txBody>
+      </p:sp>
+      <p:sp>
+        <p:nvSpPr>
+          <p:cNvPr id="12" name="TextBox 11"/>
+          <p:cNvSpPr txBox="1"/>
+          <p:nvPr/>
+        </p:nvSpPr>
+        <p:spPr>
+          <a:xfrm>
+            <a:off x="640080" y="3840480"/>
+            <a:ext cx="10789920" cy="2011680"/>
+          </a:xfrm>
+          <a:prstGeom prst="rect">
+            <a:avLst/>
+          </a:prstGeom>
+          <a:noFill/>
+        </p:spPr>
+        <p:txBody>
+          <a:bodyPr wrap="square">
+            <a:spAutoFit/>
+          </a:bodyPr>
+          <a:lstStyle/>
+          <a:p>
+            <a:pPr algn="l">
+              <a:spcAft>
+                <a:spcPts val="400"/>
+              </a:spcAft>
+              <a:defRPr sz="1300" b="1" i="0">
+                <a:solidFill>
+                  <a:srgbClr val="0070C0"/>
+                </a:solidFill>
+                <a:latin typeface="Calibri"/>
+              </a:defRPr>
+            </a:pPr>
+            <a:r>
+              <a:t>SOURCE:</a:t>
+            </a:r>
+          </a:p>
+          <a:p>
+            <a:pPr algn="l">
+              <a:spcAft>
+                <a:spcPts val="400"/>
+              </a:spcAft>
+              <a:defRPr sz="1200" b="1" i="1">
                 <a:solidFill>
                   <a:srgbClr val="000000"/>
                 </a:solidFill>
@@ -5122,15 +5077,31 @@
               </a:defRPr>
             </a:pPr>
             <a:r>
-              <a:t>    → Direct quote: "...", (Author, Year, p.X)</a:t>
-            </a:r>
-          </a:p>
-          <a:p>
-            <a:pPr>
+              <a:t>"...additional touch points, direct transactions, and data gathering..." (Cunningham and Eastin, 2015)</a:t>
+            </a:r>
+          </a:p>
+          <a:p>
+            <a:pPr algn="l">
               <a:spcAft>
-                <a:spcPts val="2800"/>
+                <a:spcPts val="400"/>
               </a:spcAft>
-              <a:defRPr sz="1800" b="1">
+              <a:defRPr sz="1300" b="1" i="0">
+                <a:solidFill>
+                  <a:srgbClr val="0070C0"/>
+                </a:solidFill>
+                <a:latin typeface="Calibri"/>
+              </a:defRPr>
+            </a:pPr>
+            <a:r>
+              <a:t>CORRECT USE:</a:t>
+            </a:r>
+          </a:p>
+          <a:p>
+            <a:pPr algn="l">
+              <a:spcAft>
+                <a:spcPts val="600"/>
+              </a:spcAft>
+              <a:defRPr sz="1200" b="1" i="1">
                 <a:solidFill>
                   <a:srgbClr val="000000"/>
                 </a:solidFill>
@@ -5138,39 +5109,23 @@
               </a:defRPr>
             </a:pPr>
             <a:r>
-              <a:t>    → Secondary: (Author, Year cited in Author, Year, p.X)</a:t>
-            </a:r>
-          </a:p>
-          <a:p>
-            <a:pPr>
+              <a:t>"The second screen offers a new opportunity to the audience to be more interactive, including 'additional touch points, direct transactions, and data gathering' (Cunningham and Eastin, 2015, p.289)."</a:t>
+            </a:r>
+          </a:p>
+          <a:p>
+            <a:pPr algn="l">
               <a:spcAft>
-                <a:spcPts val="2800"/>
+                <a:spcPts val="0"/>
               </a:spcAft>
-              <a:defRPr sz="1800" b="1">
-                <a:solidFill>
-                  <a:srgbClr val="000000"/>
-                </a:solidFill>
-                <a:latin typeface="Calibri"/>
-              </a:defRPr>
-            </a:pPr>
-            <a:r>
-              <a:t>●  Strategy 3: Quotation marks for untranslatable terms</a:t>
-            </a:r>
-          </a:p>
-          <a:p>
-            <a:pPr>
-              <a:spcAft>
-                <a:spcPts val="2800"/>
-              </a:spcAft>
-              <a:defRPr sz="1800" b="1">
-                <a:solidFill>
-                  <a:srgbClr val="000000"/>
-                </a:solidFill>
-                <a:latin typeface="Calibri"/>
-              </a:defRPr>
-            </a:pPr>
-            <a:r>
-              <a:t>    → e.g. "...additional touch points, direct transactions..."</a:t>
+              <a:defRPr sz="1300" b="1" i="0">
+                <a:solidFill>
+                  <a:srgbClr val="0070C0"/>
+                </a:solidFill>
+                <a:latin typeface="Calibri"/>
+              </a:defRPr>
+            </a:pPr>
+            <a:r>
+              <a:t>✅ Fixed terms that cannot be easily rephrased → put in quotation marks + cite with page number</a:t>
             </a:r>
           </a:p>
         </p:txBody>
@@ -5310,7 +5265,7 @@
           <a:lstStyle/>
           <a:p>
             <a:pPr algn="l">
-              <a:defRPr sz="1800" b="1">
+              <a:defRPr sz="1800" b="1" i="0">
                 <a:solidFill>
                   <a:srgbClr val="502379"/>
                 </a:solidFill>
@@ -5318,7 +5273,7 @@
               </a:defRPr>
             </a:pPr>
             <a:r>
-              <a:t>Proofreading = the difference between passing and failing</a:t>
+              <a:t>Summarise + cite correctly + quote sparingly = no plagiarism</a:t>
             </a:r>
           </a:p>
         </p:txBody>
@@ -5346,7 +5301,7 @@
           <a:lstStyle/>
           <a:p>
             <a:pPr algn="r">
-              <a:defRPr sz="1200" b="0">
+              <a:defRPr sz="1200" b="0" i="0">
                 <a:solidFill>
                   <a:srgbClr val="502379"/>
                 </a:solidFill>
@@ -5382,7 +5337,7 @@
           <a:lstStyle/>
           <a:p>
             <a:pPr algn="l">
-              <a:defRPr sz="2800" b="1">
+              <a:defRPr sz="2800" b="1" i="0">
                 <a:solidFill>
                   <a:srgbClr val="502379"/>
                 </a:solidFill>
@@ -5390,27 +5345,188 @@
               </a:defRPr>
             </a:pPr>
             <a:r>
-              <a:t>Proofreading: Final Check Before Submission</a:t>
-            </a:r>
-          </a:p>
-        </p:txBody>
-      </p:sp>
-      <p:sp>
-        <p:nvSpPr>
-          <p:cNvPr id="7" name="Oval 6"/>
+              <a:t>Solutions: How to Rewrite Correctly</a:t>
+            </a:r>
+          </a:p>
+        </p:txBody>
+      </p:sp>
+      <p:sp>
+        <p:nvSpPr>
+          <p:cNvPr id="7" name="TextBox 6"/>
+          <p:cNvSpPr txBox="1"/>
+          <p:nvPr/>
+        </p:nvSpPr>
+        <p:spPr>
+          <a:xfrm>
+            <a:off x="640080" y="1463040"/>
+            <a:ext cx="10058400" cy="4114800"/>
+          </a:xfrm>
+          <a:prstGeom prst="rect">
+            <a:avLst/>
+          </a:prstGeom>
+          <a:noFill/>
+        </p:spPr>
+        <p:txBody>
+          <a:bodyPr wrap="square">
+            <a:spAutoFit/>
+          </a:bodyPr>
+          <a:lstStyle/>
+          <a:p>
+            <a:pPr algn="l">
+              <a:spcAft>
+                <a:spcPts val="1000"/>
+              </a:spcAft>
+              <a:defRPr sz="1800" b="1" i="0">
+                <a:solidFill>
+                  <a:srgbClr val="000000"/>
+                </a:solidFill>
+                <a:latin typeface="Calibri"/>
+              </a:defRPr>
+            </a:pPr>
+            <a:r>
+              <a:t>●  Strategy 1: Summarise in your own words</a:t>
+            </a:r>
+          </a:p>
+          <a:p>
+            <a:pPr algn="l">
+              <a:spcAft>
+                <a:spcPts val="1000"/>
+              </a:spcAft>
+              <a:defRPr sz="1800" b="1" i="0">
+                <a:solidFill>
+                  <a:srgbClr val="000000"/>
+                </a:solidFill>
+                <a:latin typeface="Calibri"/>
+              </a:defRPr>
+            </a:pPr>
+            <a:r>
+              <a:t>    → Read → cover → write from memory → check against original</a:t>
+            </a:r>
+          </a:p>
+          <a:p>
+            <a:pPr algn="l">
+              <a:spcAft>
+                <a:spcPts val="1000"/>
+              </a:spcAft>
+              <a:defRPr sz="1800" b="1" i="0">
+                <a:solidFill>
+                  <a:srgbClr val="000000"/>
+                </a:solidFill>
+                <a:latin typeface="Calibri"/>
+              </a:defRPr>
+            </a:pPr>
+            <a:r>
+              <a:t>●  Strategy 2: Use correct citation format</a:t>
+            </a:r>
+          </a:p>
+          <a:p>
+            <a:pPr algn="l">
+              <a:spcAft>
+                <a:spcPts val="1000"/>
+              </a:spcAft>
+              <a:defRPr sz="1800" b="1" i="0">
+                <a:solidFill>
+                  <a:srgbClr val="000000"/>
+                </a:solidFill>
+                <a:latin typeface="Calibri"/>
+              </a:defRPr>
+            </a:pPr>
+            <a:r>
+              <a:t>    → Direct quote: "...", (Author, Year, p.X)</a:t>
+            </a:r>
+          </a:p>
+          <a:p>
+            <a:pPr algn="l">
+              <a:spcAft>
+                <a:spcPts val="1000"/>
+              </a:spcAft>
+              <a:defRPr sz="1800" b="1" i="0">
+                <a:solidFill>
+                  <a:srgbClr val="000000"/>
+                </a:solidFill>
+                <a:latin typeface="Calibri"/>
+              </a:defRPr>
+            </a:pPr>
+            <a:r>
+              <a:t>    → Secondary source: (Author, Year cited in Author, Year, p.X)</a:t>
+            </a:r>
+          </a:p>
+          <a:p>
+            <a:pPr algn="l">
+              <a:spcAft>
+                <a:spcPts val="1000"/>
+              </a:spcAft>
+              <a:defRPr sz="1800" b="1" i="0">
+                <a:solidFill>
+                  <a:srgbClr val="000000"/>
+                </a:solidFill>
+                <a:latin typeface="Calibri"/>
+              </a:defRPr>
+            </a:pPr>
+            <a:r>
+              <a:t>●  Strategy 3: Quotation marks for fixed terms only</a:t>
+            </a:r>
+          </a:p>
+          <a:p>
+            <a:pPr algn="l">
+              <a:spcAft>
+                <a:spcPts val="1000"/>
+              </a:spcAft>
+              <a:defRPr sz="1800" b="1" i="0">
+                <a:solidFill>
+                  <a:srgbClr val="000000"/>
+                </a:solidFill>
+                <a:latin typeface="Calibri"/>
+              </a:defRPr>
+            </a:pPr>
+            <a:r>
+              <a:t>    → Paraphrase first; use quotes only when impossible to reword</a:t>
+            </a:r>
+          </a:p>
+        </p:txBody>
+      </p:sp>
+    </p:spTree>
+  </p:cSld>
+  <p:clrMapOvr>
+    <a:masterClrMapping/>
+  </p:clrMapOvr>
+</p:sld>
+</file>
+
+<file path=ppt/slides/slide8.xml><?xml version="1.0" encoding="utf-8"?>
+<p:sld xmlns:a="http://schemas.openxmlformats.org/drawingml/2006/main" xmlns:p="http://schemas.openxmlformats.org/presentationml/2006/main" xmlns:r="http://schemas.openxmlformats.org/officeDocument/2006/relationships">
+  <p:cSld>
+    <p:bg>
+      <p:bgPr>
+        <a:solidFill>
+          <a:srgbClr val="FFFFFF"/>
+        </a:solidFill>
+        <a:effectLst/>
+      </p:bgPr>
+    </p:bg>
+    <p:spTree>
+      <p:nvGrpSpPr>
+        <p:cNvPr id="1" name=""/>
+        <p:cNvGrpSpPr/>
+        <p:nvPr/>
+      </p:nvGrpSpPr>
+      <p:grpSpPr/>
+      <p:sp>
+        <p:nvSpPr>
+          <p:cNvPr id="2" name="Rectangle 1"/>
           <p:cNvSpPr/>
           <p:nvPr/>
         </p:nvSpPr>
         <p:spPr>
           <a:xfrm>
-            <a:off x="10820095" y="274320"/>
-            <a:ext cx="731520" cy="731520"/>
-          </a:xfrm>
-          <a:prstGeom prst="ellipse">
+            <a:off x="0" y="0"/>
+            <a:ext cx="411480" cy="6858000"/>
+          </a:xfrm>
+          <a:prstGeom prst="rect">
             <a:avLst/>
           </a:prstGeom>
           <a:solidFill>
-            <a:srgbClr val="4A90D9"/>
+            <a:srgbClr val="502379"/>
           </a:solidFill>
           <a:ln>
             <a:noFill/>
@@ -5431,32 +5547,66 @@
           </a:fontRef>
         </p:style>
         <p:txBody>
-          <a:bodyPr rtlCol="0" anchor="ctr" wrap="none"/>
-          <a:lstStyle/>
-          <a:p>
-            <a:pPr algn="ctr">
-              <a:defRPr sz="2400">
-                <a:solidFill>
-                  <a:srgbClr val="FFFFFF"/>
-                </a:solidFill>
-              </a:defRPr>
-            </a:pPr>
-            <a:r>
-              <a:t>⏸</a:t>
-            </a:r>
-          </a:p>
-        </p:txBody>
-      </p:sp>
-      <p:sp>
-        <p:nvSpPr>
-          <p:cNvPr id="8" name="TextBox 7"/>
+          <a:bodyPr rtlCol="0" anchor="ctr"/>
+          <a:lstStyle/>
+          <a:p>
+            <a:pPr algn="ctr"/>
+          </a:p>
+        </p:txBody>
+      </p:sp>
+      <p:sp>
+        <p:nvSpPr>
+          <p:cNvPr id="3" name="Rectangle 2"/>
+          <p:cNvSpPr/>
+          <p:nvPr/>
+        </p:nvSpPr>
+        <p:spPr>
+          <a:xfrm>
+            <a:off x="0" y="6263640"/>
+            <a:ext cx="12191695" cy="594360"/>
+          </a:xfrm>
+          <a:prstGeom prst="rect">
+            <a:avLst/>
+          </a:prstGeom>
+          <a:solidFill>
+            <a:srgbClr val="F5F0FA"/>
+          </a:solidFill>
+          <a:ln>
+            <a:noFill/>
+          </a:ln>
+        </p:spPr>
+        <p:style>
+          <a:lnRef idx="1">
+            <a:schemeClr val="accent1"/>
+          </a:lnRef>
+          <a:fillRef idx="3">
+            <a:schemeClr val="accent1"/>
+          </a:fillRef>
+          <a:effectRef idx="2">
+            <a:schemeClr val="accent1"/>
+          </a:effectRef>
+          <a:fontRef idx="minor">
+            <a:schemeClr val="lt1"/>
+          </a:fontRef>
+        </p:style>
+        <p:txBody>
+          <a:bodyPr rtlCol="0" anchor="ctr"/>
+          <a:lstStyle/>
+          <a:p>
+            <a:pPr algn="ctr"/>
+          </a:p>
+        </p:txBody>
+      </p:sp>
+      <p:sp>
+        <p:nvSpPr>
+          <p:cNvPr id="4" name="TextBox 3"/>
           <p:cNvSpPr txBox="1"/>
           <p:nvPr/>
         </p:nvSpPr>
         <p:spPr>
           <a:xfrm>
-            <a:off x="640080" y="1463040"/>
-            <a:ext cx="8229600" cy="3657600"/>
+            <a:off x="640080" y="6355080"/>
+            <a:ext cx="11277295" cy="411480"/>
           </a:xfrm>
           <a:prstGeom prst="rect">
             <a:avLst/>
@@ -5469,11 +5619,119 @@
           </a:bodyPr>
           <a:lstStyle/>
           <a:p>
-            <a:pPr>
+            <a:pPr algn="l">
+              <a:defRPr sz="1800" b="1" i="0">
+                <a:solidFill>
+                  <a:srgbClr val="502379"/>
+                </a:solidFill>
+                <a:latin typeface="Calibri"/>
+              </a:defRPr>
+            </a:pPr>
+            <a:r>
+              <a:t>Proofreading = the difference between passing and failing</a:t>
+            </a:r>
+          </a:p>
+        </p:txBody>
+      </p:sp>
+      <p:sp>
+        <p:nvSpPr>
+          <p:cNvPr id="5" name="TextBox 4"/>
+          <p:cNvSpPr txBox="1"/>
+          <p:nvPr/>
+        </p:nvSpPr>
+        <p:spPr>
+          <a:xfrm>
+            <a:off x="11460175" y="6355080"/>
+            <a:ext cx="548640" cy="411480"/>
+          </a:xfrm>
+          <a:prstGeom prst="rect">
+            <a:avLst/>
+          </a:prstGeom>
+          <a:noFill/>
+        </p:spPr>
+        <p:txBody>
+          <a:bodyPr wrap="square">
+            <a:spAutoFit/>
+          </a:bodyPr>
+          <a:lstStyle/>
+          <a:p>
+            <a:pPr algn="r">
+              <a:defRPr sz="1200" b="0" i="0">
+                <a:solidFill>
+                  <a:srgbClr val="502379"/>
+                </a:solidFill>
+                <a:latin typeface="Calibri"/>
+              </a:defRPr>
+            </a:pPr>
+            <a:r>
+              <a:t>8</a:t>
+            </a:r>
+          </a:p>
+        </p:txBody>
+      </p:sp>
+      <p:sp>
+        <p:nvSpPr>
+          <p:cNvPr id="6" name="TextBox 5"/>
+          <p:cNvSpPr txBox="1"/>
+          <p:nvPr/>
+        </p:nvSpPr>
+        <p:spPr>
+          <a:xfrm>
+            <a:off x="640080" y="274320"/>
+            <a:ext cx="10058400" cy="731520"/>
+          </a:xfrm>
+          <a:prstGeom prst="rect">
+            <a:avLst/>
+          </a:prstGeom>
+          <a:noFill/>
+        </p:spPr>
+        <p:txBody>
+          <a:bodyPr wrap="square">
+            <a:spAutoFit/>
+          </a:bodyPr>
+          <a:lstStyle/>
+          <a:p>
+            <a:pPr algn="l">
+              <a:defRPr sz="2800" b="1" i="0">
+                <a:solidFill>
+                  <a:srgbClr val="502379"/>
+                </a:solidFill>
+                <a:latin typeface="Calibri"/>
+              </a:defRPr>
+            </a:pPr>
+            <a:r>
+              <a:t>Proofreading: Final Check Before Submission</a:t>
+            </a:r>
+          </a:p>
+        </p:txBody>
+      </p:sp>
+      <p:sp>
+        <p:nvSpPr>
+          <p:cNvPr id="7" name="TextBox 6"/>
+          <p:cNvSpPr txBox="1"/>
+          <p:nvPr/>
+        </p:nvSpPr>
+        <p:spPr>
+          <a:xfrm>
+            <a:off x="640080" y="1463040"/>
+            <a:ext cx="8229600" cy="3657600"/>
+          </a:xfrm>
+          <a:prstGeom prst="rect">
+            <a:avLst/>
+          </a:prstGeom>
+          <a:noFill/>
+        </p:spPr>
+        <p:txBody>
+          <a:bodyPr wrap="square">
+            <a:spAutoFit/>
+          </a:bodyPr>
+          <a:lstStyle/>
+          <a:p>
+            <a:pPr algn="l">
               <a:spcAft>
-                <a:spcPts val="3000"/>
+                <a:spcPts val="1000"/>
               </a:spcAft>
-              <a:defRPr sz="2000" b="1">
+              <a:defRPr sz="2000" b="1" i="0">
                 <a:solidFill>
                   <a:srgbClr val="000000"/>
                 </a:solidFill>
@@ -5485,11 +5743,11 @@
             </a:r>
           </a:p>
           <a:p>
-            <a:pPr>
+            <a:pPr algn="l">
               <a:spcAft>
-                <a:spcPts val="3000"/>
+                <a:spcPts val="1000"/>
               </a:spcAft>
-              <a:defRPr sz="2000" b="1">
+              <a:defRPr sz="2000" b="1" i="0">
                 <a:solidFill>
                   <a:srgbClr val="000000"/>
                 </a:solidFill>
@@ -5501,11 +5759,11 @@
             </a:r>
           </a:p>
           <a:p>
-            <a:pPr>
+            <a:pPr algn="l">
               <a:spcAft>
-                <a:spcPts val="3000"/>
+                <a:spcPts val="1000"/>
               </a:spcAft>
-              <a:defRPr sz="2000" b="1">
+              <a:defRPr sz="2000" b="1" i="0">
                 <a:solidFill>
                   <a:srgbClr val="000000"/>
                 </a:solidFill>
@@ -5517,11 +5775,11 @@
             </a:r>
           </a:p>
           <a:p>
-            <a:pPr>
+            <a:pPr algn="l">
               <a:spcAft>
-                <a:spcPts val="3000"/>
+                <a:spcPts val="1000"/>
               </a:spcAft>
-              <a:defRPr sz="2000" b="1">
+              <a:defRPr sz="2000" b="1" i="0">
                 <a:solidFill>
                   <a:srgbClr val="000000"/>
                 </a:solidFill>
@@ -5533,11 +5791,11 @@
             </a:r>
           </a:p>
           <a:p>
-            <a:pPr>
+            <a:pPr algn="l">
               <a:spcAft>
-                <a:spcPts val="3000"/>
+                <a:spcPts val="1000"/>
               </a:spcAft>
-              <a:defRPr sz="2000" b="1">
+              <a:defRPr sz="2000" b="1" i="0">
                 <a:solidFill>
                   <a:srgbClr val="000000"/>
                 </a:solidFill>

</xml_diff>